<commit_message>
fix: tabelas do deck com fundo preto no PowerPoint
- Toda célula sem fill explícito agora sai branca: o tableStyleId builtin não
  existe no pacote e o PowerPoint pintava as linhas com o tema (preto);
  o Keynote tolerava, o PowerPoint não
- Cabeçalhos das tabelas de segmentos/cidades/campanha no azul do template
  com texto branco — mesma identidade do PDCA

Co-Authored-By: Claude Fable 5 <noreply@anthropic.com>
</commit_message>
<xml_diff>
--- a/_NOVAS MELHORIAS/TESTE-deck-gerado-no-servidor.pptx
+++ b/_NOVAS MELHORIAS/TESTE-deck-gerado-no-servidor.pptx
@@ -4065,7 +4065,7 @@
                       <a:r>
                         <a:rPr lang="pt-BR" sz="1000" b="1" dirty="0">
                           <a:solidFill>
-                            <a:srgbClr val="52514E"/>
+                            <a:srgbClr val="FFFFFF"/>
                           </a:solidFill>
                           <a:latin typeface="Calibri"/>
                           <a:cs typeface="Calibri"/>
@@ -4080,7 +4080,9 @@
                         <a:srgbClr val="52514E"/>
                       </a:solidFill>
                     </a:lnB>
-                    <a:noFill/>
+                    <a:solidFill>
+                      <a:srgbClr val="1F3864"/>
+                    </a:solidFill>
                   </a:tcPr>
                 </a:tc>
                 <a:tc>
@@ -4099,7 +4101,7 @@
                       <a:r>
                         <a:rPr lang="pt-BR" sz="1000" b="1" dirty="0">
                           <a:solidFill>
-                            <a:srgbClr val="52514E"/>
+                            <a:srgbClr val="FFFFFF"/>
                           </a:solidFill>
                           <a:latin typeface="Calibri"/>
                           <a:cs typeface="Calibri"/>
@@ -4114,7 +4116,9 @@
                         <a:srgbClr val="52514E"/>
                       </a:solidFill>
                     </a:lnB>
-                    <a:noFill/>
+                    <a:solidFill>
+                      <a:srgbClr val="1F3864"/>
+                    </a:solidFill>
                   </a:tcPr>
                 </a:tc>
                 <a:tc>
@@ -4133,7 +4137,7 @@
                       <a:r>
                         <a:rPr lang="pt-BR" sz="1000" b="1" dirty="0">
                           <a:solidFill>
-                            <a:srgbClr val="52514E"/>
+                            <a:srgbClr val="FFFFFF"/>
                           </a:solidFill>
                           <a:latin typeface="Calibri"/>
                           <a:cs typeface="Calibri"/>
@@ -4148,7 +4152,9 @@
                         <a:srgbClr val="52514E"/>
                       </a:solidFill>
                     </a:lnB>
-                    <a:noFill/>
+                    <a:solidFill>
+                      <a:srgbClr val="1F3864"/>
+                    </a:solidFill>
                   </a:tcPr>
                 </a:tc>
                 <a:tc>
@@ -4167,7 +4173,7 @@
                       <a:r>
                         <a:rPr lang="pt-BR" sz="1000" b="1" dirty="0">
                           <a:solidFill>
-                            <a:srgbClr val="52514E"/>
+                            <a:srgbClr val="FFFFFF"/>
                           </a:solidFill>
                           <a:latin typeface="Calibri"/>
                           <a:cs typeface="Calibri"/>
@@ -4182,7 +4188,9 @@
                         <a:srgbClr val="52514E"/>
                       </a:solidFill>
                     </a:lnB>
-                    <a:noFill/>
+                    <a:solidFill>
+                      <a:srgbClr val="1F3864"/>
+                    </a:solidFill>
                   </a:tcPr>
                 </a:tc>
                 <a:tc>
@@ -4201,7 +4209,7 @@
                       <a:r>
                         <a:rPr lang="pt-BR" sz="1000" b="1" dirty="0">
                           <a:solidFill>
-                            <a:srgbClr val="52514E"/>
+                            <a:srgbClr val="FFFFFF"/>
                           </a:solidFill>
                           <a:latin typeface="Calibri"/>
                           <a:cs typeface="Calibri"/>
@@ -4216,7 +4224,9 @@
                         <a:srgbClr val="52514E"/>
                       </a:solidFill>
                     </a:lnB>
-                    <a:noFill/>
+                    <a:solidFill>
+                      <a:srgbClr val="1F3864"/>
+                    </a:solidFill>
                   </a:tcPr>
                 </a:tc>
               </a:tr>
@@ -5815,7 +5825,7 @@
                       <a:r>
                         <a:rPr lang="pt-BR" sz="1000" b="1" dirty="0">
                           <a:solidFill>
-                            <a:srgbClr val="52514E"/>
+                            <a:srgbClr val="FFFFFF"/>
                           </a:solidFill>
                           <a:latin typeface="Calibri"/>
                           <a:cs typeface="Calibri"/>
@@ -5830,7 +5840,9 @@
                         <a:srgbClr val="52514E"/>
                       </a:solidFill>
                     </a:lnB>
-                    <a:noFill/>
+                    <a:solidFill>
+                      <a:srgbClr val="1F3864"/>
+                    </a:solidFill>
                   </a:tcPr>
                 </a:tc>
                 <a:tc>
@@ -5849,7 +5861,7 @@
                       <a:r>
                         <a:rPr lang="pt-BR" sz="1000" b="1" dirty="0">
                           <a:solidFill>
-                            <a:srgbClr val="52514E"/>
+                            <a:srgbClr val="FFFFFF"/>
                           </a:solidFill>
                           <a:latin typeface="Calibri"/>
                           <a:cs typeface="Calibri"/>
@@ -5864,7 +5876,9 @@
                         <a:srgbClr val="52514E"/>
                       </a:solidFill>
                     </a:lnB>
-                    <a:noFill/>
+                    <a:solidFill>
+                      <a:srgbClr val="1F3864"/>
+                    </a:solidFill>
                   </a:tcPr>
                 </a:tc>
                 <a:tc>
@@ -5883,7 +5897,7 @@
                       <a:r>
                         <a:rPr lang="pt-BR" sz="1000" b="1" dirty="0">
                           <a:solidFill>
-                            <a:srgbClr val="52514E"/>
+                            <a:srgbClr val="FFFFFF"/>
                           </a:solidFill>
                           <a:latin typeface="Calibri"/>
                           <a:cs typeface="Calibri"/>
@@ -5898,7 +5912,9 @@
                         <a:srgbClr val="52514E"/>
                       </a:solidFill>
                     </a:lnB>
-                    <a:noFill/>
+                    <a:solidFill>
+                      <a:srgbClr val="1F3864"/>
+                    </a:solidFill>
                   </a:tcPr>
                 </a:tc>
                 <a:tc>
@@ -5917,7 +5933,7 @@
                       <a:r>
                         <a:rPr lang="pt-BR" sz="1000" b="1" dirty="0">
                           <a:solidFill>
-                            <a:srgbClr val="52514E"/>
+                            <a:srgbClr val="FFFFFF"/>
                           </a:solidFill>
                           <a:latin typeface="Calibri"/>
                           <a:cs typeface="Calibri"/>
@@ -5932,7 +5948,9 @@
                         <a:srgbClr val="52514E"/>
                       </a:solidFill>
                     </a:lnB>
-                    <a:noFill/>
+                    <a:solidFill>
+                      <a:srgbClr val="1F3864"/>
+                    </a:solidFill>
                   </a:tcPr>
                 </a:tc>
               </a:tr>
@@ -9785,7 +9803,7 @@
                       <a:r>
                         <a:rPr lang="pt-BR" sz="1000" b="1" dirty="0">
                           <a:solidFill>
-                            <a:srgbClr val="52514E"/>
+                            <a:srgbClr val="FFFFFF"/>
                           </a:solidFill>
                           <a:latin typeface="Calibri"/>
                           <a:cs typeface="Calibri"/>
@@ -9800,7 +9818,9 @@
                         <a:srgbClr val="52514E"/>
                       </a:solidFill>
                     </a:lnB>
-                    <a:noFill/>
+                    <a:solidFill>
+                      <a:srgbClr val="1F3864"/>
+                    </a:solidFill>
                   </a:tcPr>
                 </a:tc>
                 <a:tc>
@@ -9819,7 +9839,7 @@
                       <a:r>
                         <a:rPr lang="pt-BR" sz="1000" b="1" dirty="0">
                           <a:solidFill>
-                            <a:srgbClr val="52514E"/>
+                            <a:srgbClr val="FFFFFF"/>
                           </a:solidFill>
                           <a:latin typeface="Calibri"/>
                           <a:cs typeface="Calibri"/>
@@ -9834,7 +9854,9 @@
                         <a:srgbClr val="52514E"/>
                       </a:solidFill>
                     </a:lnB>
-                    <a:noFill/>
+                    <a:solidFill>
+                      <a:srgbClr val="1F3864"/>
+                    </a:solidFill>
                   </a:tcPr>
                 </a:tc>
                 <a:tc>
@@ -9853,7 +9875,7 @@
                       <a:r>
                         <a:rPr lang="pt-BR" sz="1000" b="1" dirty="0">
                           <a:solidFill>
-                            <a:srgbClr val="52514E"/>
+                            <a:srgbClr val="FFFFFF"/>
                           </a:solidFill>
                           <a:latin typeface="Calibri"/>
                           <a:cs typeface="Calibri"/>
@@ -9868,7 +9890,9 @@
                         <a:srgbClr val="52514E"/>
                       </a:solidFill>
                     </a:lnB>
-                    <a:noFill/>
+                    <a:solidFill>
+                      <a:srgbClr val="1F3864"/>
+                    </a:solidFill>
                   </a:tcPr>
                 </a:tc>
                 <a:tc>
@@ -9887,7 +9911,7 @@
                       <a:r>
                         <a:rPr lang="pt-BR" sz="1000" b="1" dirty="0">
                           <a:solidFill>
-                            <a:srgbClr val="52514E"/>
+                            <a:srgbClr val="FFFFFF"/>
                           </a:solidFill>
                           <a:latin typeface="Calibri"/>
                           <a:cs typeface="Calibri"/>
@@ -9902,7 +9926,9 @@
                         <a:srgbClr val="52514E"/>
                       </a:solidFill>
                     </a:lnB>
-                    <a:noFill/>
+                    <a:solidFill>
+                      <a:srgbClr val="1F3864"/>
+                    </a:solidFill>
                   </a:tcPr>
                 </a:tc>
                 <a:tc>
@@ -9921,7 +9947,7 @@
                       <a:r>
                         <a:rPr lang="pt-BR" sz="1000" b="1" dirty="0">
                           <a:solidFill>
-                            <a:srgbClr val="52514E"/>
+                            <a:srgbClr val="FFFFFF"/>
                           </a:solidFill>
                           <a:latin typeface="Calibri"/>
                           <a:cs typeface="Calibri"/>
@@ -9936,7 +9962,9 @@
                         <a:srgbClr val="52514E"/>
                       </a:solidFill>
                     </a:lnB>
-                    <a:noFill/>
+                    <a:solidFill>
+                      <a:srgbClr val="1F3864"/>
+                    </a:solidFill>
                   </a:tcPr>
                 </a:tc>
               </a:tr>
@@ -11624,7 +11652,9 @@
                         <a:srgbClr val="E1E0D9"/>
                       </a:solidFill>
                     </a:lnB>
-                    <a:noFill/>
+                    <a:solidFill>
+                      <a:srgbClr val="FFFFFF"/>
+                    </a:solidFill>
                   </a:tcPr>
                 </a:tc>
                 <a:tc>
@@ -11673,7 +11703,9 @@
                         <a:srgbClr val="E1E0D9"/>
                       </a:solidFill>
                     </a:lnB>
-                    <a:noFill/>
+                    <a:solidFill>
+                      <a:srgbClr val="FFFFFF"/>
+                    </a:solidFill>
                   </a:tcPr>
                 </a:tc>
                 <a:tc>
@@ -11788,7 +11820,9 @@
                         <a:srgbClr val="E1E0D9"/>
                       </a:solidFill>
                     </a:lnB>
-                    <a:noFill/>
+                    <a:solidFill>
+                      <a:srgbClr val="FFFFFF"/>
+                    </a:solidFill>
                   </a:tcPr>
                 </a:tc>
                 <a:tc>
@@ -11837,7 +11871,9 @@
                         <a:srgbClr val="E1E0D9"/>
                       </a:solidFill>
                     </a:lnB>
-                    <a:noFill/>
+                    <a:solidFill>
+                      <a:srgbClr val="FFFFFF"/>
+                    </a:solidFill>
                   </a:tcPr>
                 </a:tc>
                 <a:tc>
@@ -11886,7 +11922,9 @@
                         <a:srgbClr val="E1E0D9"/>
                       </a:solidFill>
                     </a:lnB>
-                    <a:noFill/>
+                    <a:solidFill>
+                      <a:srgbClr val="FFFFFF"/>
+                    </a:solidFill>
                   </a:tcPr>
                 </a:tc>
                 <a:tc>
@@ -11935,7 +11973,9 @@
                         <a:srgbClr val="E1E0D9"/>
                       </a:solidFill>
                     </a:lnB>
-                    <a:noFill/>
+                    <a:solidFill>
+                      <a:srgbClr val="FFFFFF"/>
+                    </a:solidFill>
                   </a:tcPr>
                 </a:tc>
                 <a:tc>
@@ -11984,7 +12024,9 @@
                         <a:srgbClr val="E1E0D9"/>
                       </a:solidFill>
                     </a:lnB>
-                    <a:noFill/>
+                    <a:solidFill>
+                      <a:srgbClr val="FFFFFF"/>
+                    </a:solidFill>
                   </a:tcPr>
                 </a:tc>
                 <a:tc>
@@ -12084,7 +12126,9 @@
                         <a:srgbClr val="E1E0D9"/>
                       </a:solidFill>
                     </a:lnB>
-                    <a:noFill/>
+                    <a:solidFill>
+                      <a:srgbClr val="FFFFFF"/>
+                    </a:solidFill>
                   </a:tcPr>
                 </a:tc>
               </a:tr>
@@ -12641,7 +12685,9 @@
                         <a:srgbClr val="E1E0D9"/>
                       </a:solidFill>
                     </a:lnB>
-                    <a:noFill/>
+                    <a:solidFill>
+                      <a:srgbClr val="FFFFFF"/>
+                    </a:solidFill>
                   </a:tcPr>
                 </a:tc>
                 <a:tc>
@@ -12690,7 +12736,9 @@
                         <a:srgbClr val="E1E0D9"/>
                       </a:solidFill>
                     </a:lnB>
-                    <a:noFill/>
+                    <a:solidFill>
+                      <a:srgbClr val="FFFFFF"/>
+                    </a:solidFill>
                   </a:tcPr>
                 </a:tc>
                 <a:tc>
@@ -12784,7 +12832,9 @@
                         <a:srgbClr val="E1E0D9"/>
                       </a:solidFill>
                     </a:lnB>
-                    <a:noFill/>
+                    <a:solidFill>
+                      <a:srgbClr val="FFFFFF"/>
+                    </a:solidFill>
                   </a:tcPr>
                 </a:tc>
                 <a:tc>
@@ -12833,7 +12883,9 @@
                         <a:srgbClr val="E1E0D9"/>
                       </a:solidFill>
                     </a:lnB>
-                    <a:noFill/>
+                    <a:solidFill>
+                      <a:srgbClr val="FFFFFF"/>
+                    </a:solidFill>
                   </a:tcPr>
                 </a:tc>
                 <a:tc>
@@ -12882,7 +12934,9 @@
                         <a:srgbClr val="E1E0D9"/>
                       </a:solidFill>
                     </a:lnB>
-                    <a:noFill/>
+                    <a:solidFill>
+                      <a:srgbClr val="FFFFFF"/>
+                    </a:solidFill>
                   </a:tcPr>
                 </a:tc>
                 <a:tc>
@@ -12931,7 +12985,9 @@
                         <a:srgbClr val="E1E0D9"/>
                       </a:solidFill>
                     </a:lnB>
-                    <a:noFill/>
+                    <a:solidFill>
+                      <a:srgbClr val="FFFFFF"/>
+                    </a:solidFill>
                   </a:tcPr>
                 </a:tc>
                 <a:tc>
@@ -12980,7 +13036,9 @@
                         <a:srgbClr val="E1E0D9"/>
                       </a:solidFill>
                     </a:lnB>
-                    <a:noFill/>
+                    <a:solidFill>
+                      <a:srgbClr val="FFFFFF"/>
+                    </a:solidFill>
                   </a:tcPr>
                 </a:tc>
                 <a:tc>
@@ -13080,7 +13138,9 @@
                         <a:srgbClr val="E1E0D9"/>
                       </a:solidFill>
                     </a:lnB>
-                    <a:noFill/>
+                    <a:solidFill>
+                      <a:srgbClr val="FFFFFF"/>
+                    </a:solidFill>
                   </a:tcPr>
                 </a:tc>
               </a:tr>
@@ -14555,7 +14615,9 @@
                         <a:srgbClr val="E1E0D9"/>
                       </a:solidFill>
                     </a:lnB>
-                    <a:noFill/>
+                    <a:solidFill>
+                      <a:srgbClr val="FFFFFF"/>
+                    </a:solidFill>
                   </a:tcPr>
                 </a:tc>
                 <a:tc>
@@ -14604,7 +14666,9 @@
                         <a:srgbClr val="E1E0D9"/>
                       </a:solidFill>
                     </a:lnB>
-                    <a:noFill/>
+                    <a:solidFill>
+                      <a:srgbClr val="FFFFFF"/>
+                    </a:solidFill>
                   </a:tcPr>
                 </a:tc>
                 <a:tc>
@@ -14698,7 +14762,9 @@
                         <a:srgbClr val="E1E0D9"/>
                       </a:solidFill>
                     </a:lnB>
-                    <a:noFill/>
+                    <a:solidFill>
+                      <a:srgbClr val="FFFFFF"/>
+                    </a:solidFill>
                   </a:tcPr>
                 </a:tc>
                 <a:tc>
@@ -14747,7 +14813,9 @@
                         <a:srgbClr val="E1E0D9"/>
                       </a:solidFill>
                     </a:lnB>
-                    <a:noFill/>
+                    <a:solidFill>
+                      <a:srgbClr val="FFFFFF"/>
+                    </a:solidFill>
                   </a:tcPr>
                 </a:tc>
                 <a:tc>
@@ -14796,7 +14864,9 @@
                         <a:srgbClr val="E1E0D9"/>
                       </a:solidFill>
                     </a:lnB>
-                    <a:noFill/>
+                    <a:solidFill>
+                      <a:srgbClr val="FFFFFF"/>
+                    </a:solidFill>
                   </a:tcPr>
                 </a:tc>
                 <a:tc>
@@ -14845,7 +14915,9 @@
                         <a:srgbClr val="E1E0D9"/>
                       </a:solidFill>
                     </a:lnB>
-                    <a:noFill/>
+                    <a:solidFill>
+                      <a:srgbClr val="FFFFFF"/>
+                    </a:solidFill>
                   </a:tcPr>
                 </a:tc>
                 <a:tc>
@@ -14894,7 +14966,9 @@
                         <a:srgbClr val="E1E0D9"/>
                       </a:solidFill>
                     </a:lnB>
-                    <a:noFill/>
+                    <a:solidFill>
+                      <a:srgbClr val="FFFFFF"/>
+                    </a:solidFill>
                   </a:tcPr>
                 </a:tc>
                 <a:tc>
@@ -14994,7 +15068,9 @@
                         <a:srgbClr val="E1E0D9"/>
                       </a:solidFill>
                     </a:lnB>
-                    <a:noFill/>
+                    <a:solidFill>
+                      <a:srgbClr val="FFFFFF"/>
+                    </a:solidFill>
                   </a:tcPr>
                 </a:tc>
               </a:tr>

</xml_diff>